<commit_message>
Consistent punctuation in docs, UI and logs; rebuilt PDFs, slides, diagram and video
</commit_message>
<xml_diff>
--- a/docs/presentation.pptx
+++ b/docs/presentation.pptx
@@ -3023,7 +3023,7 @@
                           <a:ea typeface="Calibri" pitchFamily="34" charset="-122"/>
                           <a:cs typeface="Calibri" pitchFamily="34" charset="-120"/>
                         </a:rPr>
-                        <a:t>Stages 1–2 implemented, stage 3 not offered</a:t>
+                        <a:t>Stages 1 and 2 implemented, stage 3 not offered</a:t>
                       </a:r>
                       <a:endParaRPr lang="en-US" sz="1000" dirty="0">
                         <a:latin typeface="Calibri" charset="0"/>
@@ -5144,7 +5144,7 @@
                 <a:ea typeface="Calibri" pitchFamily="34" charset="-122"/>
                 <a:cs typeface="Calibri" pitchFamily="34" charset="-120"/>
               </a:rPr>
-              <a:t>one client's month, −63% in the second</a:t>
+              <a:t>one client's month, 63% less in the second</a:t>
             </a:r>
             <a:endParaRPr lang="en-US" sz="1100" dirty="0"/>
           </a:p>
@@ -5247,7 +5247,7 @@
                 <a:ea typeface="Calibri" pitchFamily="34" charset="-122"/>
                 <a:cs typeface="Calibri" pitchFamily="34" charset="-120"/>
               </a:rPr>
-              <a:t>of work on levels 0–1 (rules, templates, small model)</a:t>
+              <a:t>of work on levels 0 and 1 (rules, templates, small model)</a:t>
             </a:r>
             <a:endParaRPr lang="en-US" sz="1100" dirty="0"/>
           </a:p>
@@ -7266,7 +7266,7 @@
                 <a:ea typeface="Calibri" pitchFamily="34" charset="-122"/>
                 <a:cs typeface="Calibri" pitchFamily="34" charset="-120"/>
               </a:rPr>
-              <a:t>Demo: one month for one client, scenarios C1–C10</a:t>
+              <a:t>Demo: one month for one client, scenarios C1 to C10</a:t>
             </a:r>
             <a:endParaRPr lang="en-US" sz="2800" dirty="0"/>
           </a:p>
@@ -10260,7 +10260,7 @@
                 <a:ea typeface="Calibri" pitchFamily="34" charset="-122"/>
                 <a:cs typeface="Calibri" pitchFamily="34" charset="-120"/>
               </a:rPr>
-              <a:t>Trust levels 0–2  </a:t>
+              <a:t>Trust levels 0, 1, 2  </a:t>
             </a:r>
             <a:pPr indent="0" marL="0">
               <a:buNone/>
@@ -10274,7 +10274,7 @@
                 <a:ea typeface="Calibri" pitchFamily="34" charset="-122"/>
                 <a:cs typeface="Calibri" pitchFamily="34" charset="-120"/>
               </a:rPr>
-              <a:t>Level 1 limit 1 000 ₽; promotion after 5 verified results in a row. Autonomy stages 1–2, stage 3 not offered.</a:t>
+              <a:t>Level 1 limit 1 000 ₽; promotion after 5 verified results in a row. Autonomy stages 1 and 2, stage 3 not offered.</a:t>
             </a:r>
             <a:endParaRPr lang="en-US" sz="1200" dirty="0"/>
           </a:p>
@@ -11900,7 +11900,7 @@
                 <a:ea typeface="Calibri" pitchFamily="34" charset="-122"/>
                 <a:cs typeface="Calibri" pitchFamily="34" charset="-120"/>
               </a:rPr>
-              <a:t>Known risks are listed openly in the security report (K1–K14): a compromised client device, a colluding analyst, synthetic training data, no SD-JWT yet.</a:t>
+              <a:t>Known risks are listed openly in the security report (K1 to K14): a compromised client device, a colluding analyst, synthetic training data, no SD-JWT yet.</a:t>
             </a:r>
             <a:endParaRPr lang="en-US" sz="1200" dirty="0"/>
           </a:p>

</xml_diff>

<commit_message>
Team names on the documents and the title slide
</commit_message>
<xml_diff>
--- a/docs/presentation.pptx
+++ b/docs/presentation.pptx
@@ -1208,7 +1208,7 @@
           <a:p>
             <a:r>
               <a:rPr lang="en-US" dirty="0"/>
-              <a:t>Hello. We are the Guardian team. Our topic is A: an AI agent that pays, cancels and budgets for a bank client. In ten minutes: the problem, the idea, a month of the demo, how the kernel works, the security results, compliance, cost and what is next.</a:t>
+              <a:t>Hello. We are Kseniia Kuzmina and Nikita Stepanov, the Guardian team. Our topic is A: an AI agent that pays, cancels and budgets for a bank client. In ten minutes: the problem, the idea, a month of the demo, how the kernel works, the security results, compliance, cost and what is next.</a:t>
             </a:r>
             <a:endParaRPr lang="en-US" dirty="0"/>
           </a:p>
@@ -2674,6 +2674,45 @@
         </p:nvSpPr>
         <p:spPr>
           <a:xfrm>
+            <a:off x="548640" y="3840480"/>
+            <a:ext cx="8046720" cy="365760"/>
+          </a:xfrm>
+          <a:prstGeom prst="rect">
+            <a:avLst/>
+          </a:prstGeom>
+          <a:noFill/>
+          <a:ln/>
+        </p:spPr>
+        <p:txBody>
+          <a:bodyPr wrap="square" lIns="0" tIns="0" rIns="0" bIns="0" rtlCol="0" anchor="ctr"/>
+          <a:lstStyle/>
+          <a:p>
+            <a:pPr indent="0" marL="0">
+              <a:buNone/>
+            </a:pPr>
+            <a:r>
+              <a:rPr lang="en-US" sz="1500" b="1" dirty="0">
+                <a:solidFill>
+                  <a:srgbClr val="FFFFFF"/>
+                </a:solidFill>
+                <a:latin typeface="Calibri" pitchFamily="34" charset="0"/>
+                <a:ea typeface="Calibri" pitchFamily="34" charset="-122"/>
+                <a:cs typeface="Calibri" pitchFamily="34" charset="-120"/>
+              </a:rPr>
+              <a:t>Kseniia Kuzmina · Nikita Stepanov</a:t>
+            </a:r>
+            <a:endParaRPr lang="en-US" sz="1500" dirty="0"/>
+          </a:p>
+        </p:txBody>
+      </p:sp>
+      <p:sp>
+        <p:nvSpPr>
+          <p:cNvPr id="7" name="Text 4"/>
+          <p:cNvSpPr/>
+          <p:nvPr/>
+        </p:nvSpPr>
+        <p:spPr>
+          <a:xfrm>
             <a:off x="548640" y="4206240"/>
             <a:ext cx="8046720" cy="365760"/>
           </a:xfrm>

</xml_diff>

<commit_message>
Deck: thesis on the title slide, three scenes to remember, pilot with a bank, live numbers
</commit_message>
<xml_diff>
--- a/docs/presentation.pptx
+++ b/docs/presentation.pptx
@@ -19,9 +19,10 @@
     <p:sldId id="267" r:id="rId13"/>
     <p:sldId id="268" r:id="rId14"/>
     <p:sldId id="269" r:id="rId15"/>
+    <p:sldId id="270" r:id="rId16"/>
   </p:sldIdLst>
   <p:notesMasterIdLst>
-    <p:notesMasterId r:id="rId16"/>
+    <p:notesMasterId r:id="rId17"/>
   </p:notesMasterIdLst>
   <p:sldSz cx="9144000" cy="5143500"/>
   <p:notesSz cx="5143500" cy="9144000"/>
@@ -427,7 +428,7 @@
                 </a:solidFill>
                 <a:latin typeface="Arial"/>
               </a:rPr>
-              <a:t>US dollars per task, one client</a:t>
+              <a:t>US dollars per task, one client, measured live</a:t>
             </a:r>
           </a:p>
         </c:rich>
@@ -525,25 +526,25 @@
                 <c:formatCode>General</c:formatCode>
                 <c:ptCount val="7"/>
                 <c:pt idx="0">
-                  <c:v>0.003122</c:v>
+                  <c:v>0.004558</c:v>
                 </c:pt>
                 <c:pt idx="1">
-                  <c:v>0.000222</c:v>
+                  <c:v>0.000308</c:v>
                 </c:pt>
                 <c:pt idx="2">
-                  <c:v>0.000395</c:v>
+                  <c:v>0.000684</c:v>
                 </c:pt>
                 <c:pt idx="3">
-                  <c:v>0.00261</c:v>
+                  <c:v>0.004408</c:v>
                 </c:pt>
                 <c:pt idx="4">
-                  <c:v>0.000306</c:v>
+                  <c:v>0.000545</c:v>
                 </c:pt>
                 <c:pt idx="5">
-                  <c:v>0.000413</c:v>
+                  <c:v>0.000606</c:v>
                 </c:pt>
                 <c:pt idx="6">
-                  <c:v>0.000172</c:v>
+                  <c:v>0.000305</c:v>
                 </c:pt>
               </c:numCache>
             </c:numRef>
@@ -635,22 +636,22 @@
                   <c:v>0</c:v>
                 </c:pt>
                 <c:pt idx="1">
-                  <c:v>0.000222</c:v>
+                  <c:v>0.000313</c:v>
                 </c:pt>
                 <c:pt idx="2">
                   <c:v>0</c:v>
                 </c:pt>
                 <c:pt idx="3">
-                  <c:v>0.001796</c:v>
+                  <c:v>0.002751</c:v>
                 </c:pt>
                 <c:pt idx="4">
-                  <c:v>0.000187</c:v>
+                  <c:v>0.000437</c:v>
                 </c:pt>
                 <c:pt idx="5">
-                  <c:v>0.000286</c:v>
+                  <c:v>0.000461</c:v>
                 </c:pt>
                 <c:pt idx="6">
-                  <c:v>0.000166</c:v>
+                  <c:v>0.000307</c:v>
                 </c:pt>
               </c:numCache>
             </c:numRef>
@@ -1210,7 +1211,7 @@
           <a:p>
             <a:r>
               <a:rPr lang="en-US" dirty="0"/>
-              <a:t>Hello. We are Kseniia Kuzmina and Nikita Stepanov, the Guardian team. Our topic is A: an AI agent that pays, cancels and budgets for a bank client. In ten minutes: the problem, the idea, a month of the demo, how the kernel works, the security results, compliance, cost and what is next.</a:t>
+              <a:t>Hello. We are Kseniia Kuzmina and Nikita Stepanov, the Guardian team. Our topic is A: an AI agent that pays, cancels and budgets for a bank client. Our whole project in one sentence: An AI agent may propose any payment, but money moves only inside what the client signed, and the bank can prove it. In ten minutes: the problem, the idea, three scenes from the demo, how the kernel works, the security results, cost and a pilot with a bank.</a:t>
             </a:r>
             <a:endParaRPr lang="en-US" dirty="0"/>
           </a:p>
@@ -1562,7 +1563,7 @@
           <a:p>
             <a:r>
               <a:rPr lang="en-US" dirty="0"/>
-              <a:t>Cost. Models sit on a three-level ladder: rules and templates cost nothing, then a small model, then larger ones only when risk is high. For one client's typical month the first month costs $0.0072 in tokens; the next month $0.0027, 63.3 percent less, because the repeat payment and the repeated check run from templates with no model call. In the full demo 97.6 percent of the work stays on levels zero and one. At the next-month rate a million clients cost about $3,000 a month. These are token counts on the real prompts with stub answers; a live run will replace the estimate.</a:t>
+              <a:t>Cost. Models sit on a three-level ladder: rules and templates cost nothing, then a small model, then larger ones only when risk is high. For one client's typical month the first month costs $0.0114 in tokens; the next month $0.0043, 62.6 percent less, because the repeat payment and the repeated check run from templates with no model call. In the full demo 97.6 percent of the work stays on levels zero and one. At the next-month rate a million clients cost about $4,000 a month. These numbers are measured on a live run with real models: claude-haiku-4-5-20251001 on level one, claude-sonnet-5-5 and claude-opus-5-5 above it.</a:t>
             </a:r>
             <a:endParaRPr lang="en-US" dirty="0"/>
           </a:p>
@@ -1650,7 +1651,7 @@
           <a:p>
             <a:r>
               <a:rPr lang="en-US" dirty="0"/>
-              <a:t>To sum up. 48 of 48 functional tasks pass in English, Russian and Chinese, 59 of 59 attacks in the evaluation set are stopped, and the whole repository has an automated test suite that runs in the Docker build. Everything is reproducible from the repository in replay mode without any keys. Next: live runs with real models, anchoring on a public test network, the payee model on real bank graphs, and SD-JWT selective disclosure for mandates. Agents propose; the kernel decides, checks and records. Thank you.</a:t>
+              <a:t>How this reaches real clients. The customer is the bank, not the client: Guardian runs inside the bank as the gate for its agent channel. The bank gets three things: fraud losses it does not pay out, a safe way to let third party AI assistants act for its clients, and audit evidence for the regulator. We propose a pilot in three stages. First, shadow mode for about three months: the kernel sees real agent requests and fraud cases, decides, but does not act, and we compare its decisions with the fraud team's. Second, the bank's own employees with real money and small caps. Third, a few thousand volunteer clients, starting with subscriptions and bills, then investing. We measure what the bank cares about: attacks stopped compared with its fraud team, how often a card asks the client without need, zero payments outside a mandate, and cost per client, which today is about $0.0043 a month in tokens.</a:t>
             </a:r>
             <a:endParaRPr lang="en-US" dirty="0"/>
           </a:p>
@@ -1674,6 +1675,94 @@
             <a:fld id="{F7021451-1387-4CA6-816F-3879F97B5CBC}" type="slidenum">
               <a:rPr lang="en-US"/>
               <a:t>14</a:t>
+            </a:fld>
+            <a:endParaRPr lang="en-US"/>
+          </a:p>
+        </p:txBody>
+      </p:sp>
+    </p:spTree>
+    <p:extLst>
+      <p:ext uri="{BB962C8B-B14F-4D97-AF65-F5344CB8AC3E}">
+        <p14:creationId xmlns:p14="http://schemas.microsoft.com/office/powerpoint/2010/main" val="1024086991"/>
+      </p:ext>
+    </p:extLst>
+  </p:cSld>
+  <p:clrMapOvr>
+    <a:masterClrMapping/>
+  </p:clrMapOvr>
+</p:notes>
+</file>
+
+<file path=ppt/notesSlides/notesSlide15.xml><?xml version="1.0" encoding="utf-8"?>
+<p:notes xmlns:a="http://schemas.openxmlformats.org/drawingml/2006/main" xmlns:r="http://schemas.openxmlformats.org/officeDocument/2006/relationships" xmlns:p="http://schemas.openxmlformats.org/presentationml/2006/main">
+  <p:cSld>
+    <p:spTree>
+      <p:nvGrpSpPr>
+        <p:cNvPr id="1" name=""/>
+        <p:cNvGrpSpPr/>
+        <p:nvPr/>
+      </p:nvGrpSpPr>
+      <p:grpSpPr>
+        <a:xfrm>
+          <a:off x="0" y="0"/>
+          <a:ext cx="0" cy="0"/>
+          <a:chOff x="0" y="0"/>
+          <a:chExt cx="0" cy="0"/>
+        </a:xfrm>
+      </p:grpSpPr>
+      <p:sp>
+        <p:nvSpPr>
+          <p:cNvPr id="2" name="Slide Image Placeholder 1"/>
+          <p:cNvSpPr>
+            <a:spLocks noGrp="1" noRot="1" noChangeAspect="1"/>
+          </p:cNvSpPr>
+          <p:nvPr>
+            <p:ph type="sldImg"/>
+          </p:nvPr>
+        </p:nvSpPr>
+        <p:spPr/>
+      </p:sp>
+      <p:sp>
+        <p:nvSpPr>
+          <p:cNvPr id="3" name="Notes Placeholder 2"/>
+          <p:cNvSpPr>
+            <a:spLocks noGrp="1"/>
+          </p:cNvSpPr>
+          <p:nvPr>
+            <p:ph type="body" idx="1"/>
+          </p:nvPr>
+        </p:nvSpPr>
+        <p:spPr/>
+        <p:txBody>
+          <a:bodyPr/>
+          <a:lstStyle/>
+          <a:p>
+            <a:r>
+              <a:rPr lang="en-US" dirty="0"/>
+              <a:t>To sum up. 48 of 48 functional tasks pass in English, Russian and Chinese, 59 of 59 attacks in the evaluation set are stopped, and the whole repository has an automated test suite that runs in the Docker build. With real models the same evaluation passes 44 of 48; every miss is the live critic stopping something a card was expected for. Everything is reproducible from the repository in replay mode without any keys. Next: the pilot with a bank, anchoring on a public test network, the payee model on real bank graphs, and SD-JWT selective disclosure for mandates. Agents propose; the kernel decides, checks and records. Thank you.</a:t>
+            </a:r>
+            <a:endParaRPr lang="en-US" dirty="0"/>
+          </a:p>
+        </p:txBody>
+      </p:sp>
+      <p:sp>
+        <p:nvSpPr>
+          <p:cNvPr id="4" name="Slide Number Placeholder 3"/>
+          <p:cNvSpPr>
+            <a:spLocks noGrp="1"/>
+          </p:cNvSpPr>
+          <p:nvPr>
+            <p:ph type="sldNum" sz="quarter" idx="10"/>
+          </p:nvPr>
+        </p:nvSpPr>
+        <p:spPr/>
+        <p:txBody>
+          <a:bodyPr/>
+          <a:lstStyle/>
+          <a:p>
+            <a:fld id="{F7021451-1387-4CA6-816F-3879F97B5CBC}" type="slidenum">
+              <a:rPr lang="en-US"/>
+              <a:t>15</a:t>
             </a:fld>
             <a:endParaRPr lang="en-US"/>
           </a:p>
@@ -2002,7 +2091,7 @@
           <a:p>
             <a:r>
               <a:rPr lang="en-US" dirty="0"/>
-              <a:t>Here is the real interface. On the left, a card. The kernel renders it, every field has its source, and you hold to sign with the device key. On the right, the fake bill. It imitates Mosenergo, the account is not Mosenergo's, it uses pressure and has a hidden instruction for AI agents, and it is linked to an earlier phishing email. The scam call, where the ladder goes from explain to ask to a pause and then holds the money for a person at the bank, is in the demo video.</a:t>
+              <a:t>If you remember three scenes from our demo, let it be these. One: a payment the client can prove. The kernel renders the card, every field has its source, the client signs it with the device key, and next month the same payment runs alone under a standing permission. Two: an attack that goes nowhere. A fake bill imitates the electricity company, the account is not theirs, and it carries a hidden instruction for AI agents. The kernel stops it with reasons and sends the case to analysts. Three: real money logic on a real exchange. The client asks to invest ten dollars a month in SPY; the kernel checks the order with its own quote and places it. On an Alpaca paper account the order filled at $767.57. Everything else in the demo, the budget, the scam call, earned trust, is the same kernel doing the same thing.</a:t>
             </a:r>
             <a:endParaRPr lang="en-US" dirty="0"/>
           </a:p>
@@ -2840,24 +2929,63 @@
         </p:nvSpPr>
         <p:spPr>
           <a:xfrm>
-            <a:off x="640080" y="3291840"/>
-            <a:ext cx="7863840" cy="457200"/>
-          </a:xfrm>
-          <a:prstGeom prst="rect">
-            <a:avLst/>
-          </a:prstGeom>
-          <a:noFill/>
-          <a:ln/>
-        </p:spPr>
-        <p:txBody>
-          <a:bodyPr wrap="square" lIns="0" tIns="0" rIns="0" bIns="0" rtlCol="0" anchor="ctr"/>
-          <a:lstStyle/>
-          <a:p>
-            <a:pPr indent="0" marL="0">
-              <a:buNone/>
-            </a:pPr>
-            <a:r>
-              <a:rPr lang="en-US" sz="2200" dirty="0">
+            <a:off x="640080" y="3063240"/>
+            <a:ext cx="7863840" cy="411480"/>
+          </a:xfrm>
+          <a:prstGeom prst="rect">
+            <a:avLst/>
+          </a:prstGeom>
+          <a:noFill/>
+          <a:ln/>
+        </p:spPr>
+        <p:txBody>
+          <a:bodyPr wrap="square" lIns="0" tIns="0" rIns="0" bIns="0" rtlCol="0" anchor="ctr"/>
+          <a:lstStyle/>
+          <a:p>
+            <a:pPr indent="0" marL="0">
+              <a:buNone/>
+            </a:pPr>
+            <a:r>
+              <a:rPr lang="en-US" sz="2000" dirty="0">
+                <a:solidFill>
+                  <a:srgbClr val="667085"/>
+                </a:solidFill>
+                <a:latin typeface="Inter" pitchFamily="34" charset="0"/>
+                <a:ea typeface="Inter" pitchFamily="34" charset="-122"/>
+                <a:cs typeface="Inter" pitchFamily="34" charset="-120"/>
+              </a:rPr>
+              <a:t>A bank-side safety kernel for AI payment agents</a:t>
+            </a:r>
+            <a:endParaRPr lang="en-US" sz="2000" dirty="0"/>
+          </a:p>
+        </p:txBody>
+      </p:sp>
+      <p:sp>
+        <p:nvSpPr>
+          <p:cNvPr id="7" name="Text 4"/>
+          <p:cNvSpPr/>
+          <p:nvPr/>
+        </p:nvSpPr>
+        <p:spPr>
+          <a:xfrm>
+            <a:off x="640080" y="3474720"/>
+            <a:ext cx="7863840" cy="685800"/>
+          </a:xfrm>
+          <a:prstGeom prst="rect">
+            <a:avLst/>
+          </a:prstGeom>
+          <a:noFill/>
+          <a:ln/>
+        </p:spPr>
+        <p:txBody>
+          <a:bodyPr wrap="square" lIns="0" tIns="0" rIns="0" bIns="0" rtlCol="0" anchor="t"/>
+          <a:lstStyle/>
+          <a:p>
+            <a:pPr indent="0" marL="0">
+              <a:buNone/>
+            </a:pPr>
+            <a:r>
+              <a:rPr lang="en-US" sz="1700" b="1" dirty="0">
                 <a:solidFill>
                   <a:srgbClr val="101828"/>
                 </a:solidFill>
@@ -2865,48 +2993,9 @@
                 <a:ea typeface="Inter" pitchFamily="34" charset="-122"/>
                 <a:cs typeface="Inter" pitchFamily="34" charset="-120"/>
               </a:rPr>
-              <a:t>A bank-side safety kernel for AI payment agents</a:t>
-            </a:r>
-            <a:endParaRPr lang="en-US" sz="2200" dirty="0"/>
-          </a:p>
-        </p:txBody>
-      </p:sp>
-      <p:sp>
-        <p:nvSpPr>
-          <p:cNvPr id="7" name="Text 4"/>
-          <p:cNvSpPr/>
-          <p:nvPr/>
-        </p:nvSpPr>
-        <p:spPr>
-          <a:xfrm>
-            <a:off x="640080" y="3749040"/>
-            <a:ext cx="7863840" cy="365760"/>
-          </a:xfrm>
-          <a:prstGeom prst="rect">
-            <a:avLst/>
-          </a:prstGeom>
-          <a:noFill/>
-          <a:ln/>
-        </p:spPr>
-        <p:txBody>
-          <a:bodyPr wrap="square" lIns="0" tIns="0" rIns="0" bIns="0" rtlCol="0" anchor="ctr"/>
-          <a:lstStyle/>
-          <a:p>
-            <a:pPr indent="0" marL="0">
-              <a:buNone/>
-            </a:pPr>
-            <a:r>
-              <a:rPr lang="en-US" sz="1500" dirty="0">
-                <a:solidFill>
-                  <a:srgbClr val="667085"/>
-                </a:solidFill>
-                <a:latin typeface="Inter" pitchFamily="34" charset="0"/>
-                <a:ea typeface="Inter" pitchFamily="34" charset="-122"/>
-                <a:cs typeface="Inter" pitchFamily="34" charset="-120"/>
-              </a:rPr>
-              <a:t>Agents propose. The kernel decides, checks and records.</a:t>
-            </a:r>
-            <a:endParaRPr lang="en-US" sz="1500" dirty="0"/>
+              <a:t>An AI agent may propose any payment, but money moves only inside what the client signed, and the bank can prove it.</a:t>
+            </a:r>
+            <a:endParaRPr lang="en-US" sz="1700" dirty="0"/>
           </a:p>
         </p:txBody>
       </p:sp>
@@ -3197,7 +3286,7 @@
                 <a:ea typeface="Inter" pitchFamily="34" charset="-122"/>
                 <a:cs typeface="Inter" pitchFamily="34" charset="-120"/>
               </a:rPr>
-              <a:t>10 / 14</a:t>
+              <a:t>10 / 15</a:t>
             </a:r>
             <a:endParaRPr lang="en-US" sz="900" dirty="0"/>
           </a:p>
@@ -4369,7 +4458,7 @@
                 <a:ea typeface="Inter" pitchFamily="34" charset="-122"/>
                 <a:cs typeface="Inter" pitchFamily="34" charset="-120"/>
               </a:rPr>
-              <a:t>11 / 14</a:t>
+              <a:t>11 / 15</a:t>
             </a:r>
             <a:endParaRPr lang="en-US" sz="900" dirty="0"/>
           </a:p>
@@ -5151,7 +5240,7 @@
                 <a:ea typeface="Inter" pitchFamily="34" charset="-122"/>
                 <a:cs typeface="Inter" pitchFamily="34" charset="-120"/>
               </a:rPr>
-              <a:t>12 / 14</a:t>
+              <a:t>12 / 15</a:t>
             </a:r>
             <a:endParaRPr lang="en-US" sz="900" dirty="0"/>
           </a:p>
@@ -7634,7 +7723,7 @@
                 <a:ea typeface="Inter" pitchFamily="34" charset="-122"/>
                 <a:cs typeface="Inter" pitchFamily="34" charset="-120"/>
               </a:rPr>
-              <a:t>13 / 14</a:t>
+              <a:t>13 / 15</a:t>
             </a:r>
             <a:endParaRPr lang="en-US" sz="900" dirty="0"/>
           </a:p>
@@ -7716,7 +7805,7 @@
                 <a:ea typeface="Inter" pitchFamily="34" charset="-122"/>
                 <a:cs typeface="Inter" pitchFamily="34" charset="-120"/>
               </a:rPr>
-              <a:t>$0.0072 → $0.0027</a:t>
+              <a:t>$0.0114 → $0.0043</a:t>
             </a:r>
             <a:endParaRPr lang="en-US" sz="2000" dirty="0"/>
           </a:p>
@@ -7926,7 +8015,7 @@
                 <a:ea typeface="Inter" pitchFamily="34" charset="-122"/>
                 <a:cs typeface="Inter" pitchFamily="34" charset="-120"/>
               </a:rPr>
-              <a:t>≈ $3,000</a:t>
+              <a:t>≈ $4,000</a:t>
             </a:r>
             <a:endParaRPr lang="en-US" sz="2600" dirty="0"/>
           </a:p>
@@ -8028,7 +8117,7 @@
               <a:buNone/>
             </a:pPr>
             <a:r>
-              <a:rPr lang="en-US" sz="2500" b="1" dirty="0">
+              <a:rPr lang="en-US" sz="2100" b="1" dirty="0">
                 <a:solidFill>
                   <a:srgbClr val="101828"/>
                 </a:solidFill>
@@ -8036,9 +8125,9 @@
                 <a:ea typeface="Inter" pitchFamily="34" charset="-122"/>
                 <a:cs typeface="Inter" pitchFamily="34" charset="-120"/>
               </a:rPr>
-              <a:t>Results and what comes next</a:t>
-            </a:r>
-            <a:endParaRPr lang="en-US" sz="2500" dirty="0"/>
+              <a:t>Pilot with a bank: who pays, how, what we measure</a:t>
+            </a:r>
+            <a:endParaRPr lang="en-US" sz="2100" dirty="0"/>
           </a:p>
         </p:txBody>
       </p:sp>
@@ -8180,7 +8269,714 @@
                 <a:ea typeface="Inter" pitchFamily="34" charset="-122"/>
                 <a:cs typeface="Inter" pitchFamily="34" charset="-120"/>
               </a:rPr>
-              <a:t>14 / 14</a:t>
+              <a:t>14 / 15</a:t>
+            </a:r>
+            <a:endParaRPr lang="en-US" sz="900" dirty="0"/>
+          </a:p>
+        </p:txBody>
+      </p:sp>
+      <p:sp>
+        <p:nvSpPr>
+          <p:cNvPr id="8" name="Shape 5"/>
+          <p:cNvSpPr/>
+          <p:nvPr/>
+        </p:nvSpPr>
+        <p:spPr>
+          <a:xfrm>
+            <a:off x="457200" y="1143000"/>
+            <a:ext cx="2651760" cy="3429000"/>
+          </a:xfrm>
+          <a:prstGeom prst="roundRect">
+            <a:avLst>
+              <a:gd name="adj" fmla="val 4138"/>
+            </a:avLst>
+          </a:prstGeom>
+          <a:solidFill>
+            <a:srgbClr val="EEF4FF"/>
+          </a:solidFill>
+          <a:ln w="12700">
+            <a:solidFill>
+              <a:srgbClr val="EEF4FF"/>
+            </a:solidFill>
+            <a:prstDash val="solid"/>
+          </a:ln>
+        </p:spPr>
+      </p:sp>
+      <p:sp>
+        <p:nvSpPr>
+          <p:cNvPr id="9" name="Text 6"/>
+          <p:cNvSpPr/>
+          <p:nvPr/>
+        </p:nvSpPr>
+        <p:spPr>
+          <a:xfrm>
+            <a:off x="640080" y="1261872"/>
+            <a:ext cx="2286000" cy="365760"/>
+          </a:xfrm>
+          <a:prstGeom prst="rect">
+            <a:avLst/>
+          </a:prstGeom>
+          <a:noFill/>
+          <a:ln/>
+        </p:spPr>
+        <p:txBody>
+          <a:bodyPr wrap="square" lIns="0" tIns="0" rIns="0" bIns="0" rtlCol="0" anchor="ctr"/>
+          <a:lstStyle/>
+          <a:p>
+            <a:pPr indent="0" marL="0">
+              <a:buNone/>
+            </a:pPr>
+            <a:r>
+              <a:rPr lang="en-US" sz="1600" b="1" dirty="0">
+                <a:solidFill>
+                  <a:srgbClr val="101828"/>
+                </a:solidFill>
+                <a:latin typeface="Inter" pitchFamily="34" charset="0"/>
+                <a:ea typeface="Inter" pitchFamily="34" charset="-122"/>
+                <a:cs typeface="Inter" pitchFamily="34" charset="-120"/>
+              </a:rPr>
+              <a:t>Who pays</a:t>
+            </a:r>
+            <a:endParaRPr lang="en-US" sz="1600" dirty="0"/>
+          </a:p>
+        </p:txBody>
+      </p:sp>
+      <p:sp>
+        <p:nvSpPr>
+          <p:cNvPr id="10" name="Text 7"/>
+          <p:cNvSpPr/>
+          <p:nvPr/>
+        </p:nvSpPr>
+        <p:spPr>
+          <a:xfrm>
+            <a:off x="640080" y="1691640"/>
+            <a:ext cx="2331720" cy="2788920"/>
+          </a:xfrm>
+          <a:prstGeom prst="rect">
+            <a:avLst/>
+          </a:prstGeom>
+          <a:noFill/>
+          <a:ln/>
+        </p:spPr>
+        <p:txBody>
+          <a:bodyPr wrap="square" lIns="0" tIns="0" rIns="0" bIns="0" rtlCol="0" anchor="t"/>
+          <a:lstStyle/>
+          <a:p>
+            <a:pPr marL="342900" indent="-342900">
+              <a:spcAft>
+                <a:spcPts val="700"/>
+              </a:spcAft>
+              <a:buSzPct val="100000"/>
+              <a:buChar char="•"/>
+            </a:pPr>
+            <a:r>
+              <a:rPr lang="en-US" sz="1150" dirty="0">
+                <a:solidFill>
+                  <a:srgbClr val="101828"/>
+                </a:solidFill>
+                <a:latin typeface="Inter" pitchFamily="34" charset="0"/>
+                <a:ea typeface="Inter" pitchFamily="34" charset="-122"/>
+                <a:cs typeface="Inter" pitchFamily="34" charset="-120"/>
+              </a:rPr>
+              <a:t>The bank: Guardian is the gate of its agent channel, a fee per active client a month</a:t>
+            </a:r>
+            <a:endParaRPr lang="en-US" sz="1150" dirty="0"/>
+          </a:p>
+          <a:p>
+            <a:pPr marL="342900" indent="-342900">
+              <a:spcAft>
+                <a:spcPts val="700"/>
+              </a:spcAft>
+              <a:buSzPct val="100000"/>
+              <a:buChar char="•"/>
+            </a:pPr>
+            <a:r>
+              <a:rPr lang="en-US" sz="1150" dirty="0">
+                <a:solidFill>
+                  <a:srgbClr val="101828"/>
+                </a:solidFill>
+                <a:latin typeface="Inter" pitchFamily="34" charset="0"/>
+                <a:ea typeface="Inter" pitchFamily="34" charset="-122"/>
+                <a:cs typeface="Inter" pitchFamily="34" charset="-120"/>
+              </a:rPr>
+              <a:t>Fraud losses not paid out</a:t>
+            </a:r>
+            <a:endParaRPr lang="en-US" sz="1150" dirty="0"/>
+          </a:p>
+          <a:p>
+            <a:pPr marL="342900" indent="-342900">
+              <a:spcAft>
+                <a:spcPts val="700"/>
+              </a:spcAft>
+              <a:buSzPct val="100000"/>
+              <a:buChar char="•"/>
+            </a:pPr>
+            <a:r>
+              <a:rPr lang="en-US" sz="1150" dirty="0">
+                <a:solidFill>
+                  <a:srgbClr val="101828"/>
+                </a:solidFill>
+                <a:latin typeface="Inter" pitchFamily="34" charset="0"/>
+                <a:ea typeface="Inter" pitchFamily="34" charset="-122"/>
+                <a:cs typeface="Inter" pitchFamily="34" charset="-120"/>
+              </a:rPr>
+              <a:t>Third party AI assistants admitted safely</a:t>
+            </a:r>
+            <a:endParaRPr lang="en-US" sz="1150" dirty="0"/>
+          </a:p>
+          <a:p>
+            <a:pPr marL="342900" indent="-342900">
+              <a:spcAft>
+                <a:spcPts val="700"/>
+              </a:spcAft>
+              <a:buSzPct val="100000"/>
+              <a:buChar char="•"/>
+            </a:pPr>
+            <a:r>
+              <a:rPr lang="en-US" sz="1150" dirty="0">
+                <a:solidFill>
+                  <a:srgbClr val="101828"/>
+                </a:solidFill>
+                <a:latin typeface="Inter" pitchFamily="34" charset="0"/>
+                <a:ea typeface="Inter" pitchFamily="34" charset="-122"/>
+                <a:cs typeface="Inter" pitchFamily="34" charset="-120"/>
+              </a:rPr>
+              <a:t>Audit evidence for the regulator</a:t>
+            </a:r>
+            <a:endParaRPr lang="en-US" sz="1150" dirty="0"/>
+          </a:p>
+        </p:txBody>
+      </p:sp>
+      <p:sp>
+        <p:nvSpPr>
+          <p:cNvPr id="11" name="Shape 8"/>
+          <p:cNvSpPr/>
+          <p:nvPr/>
+        </p:nvSpPr>
+        <p:spPr>
+          <a:xfrm>
+            <a:off x="3291840" y="1143000"/>
+            <a:ext cx="2651760" cy="3429000"/>
+          </a:xfrm>
+          <a:prstGeom prst="roundRect">
+            <a:avLst>
+              <a:gd name="adj" fmla="val 4138"/>
+            </a:avLst>
+          </a:prstGeom>
+          <a:solidFill>
+            <a:srgbClr val="F3F0FF"/>
+          </a:solidFill>
+          <a:ln w="12700">
+            <a:solidFill>
+              <a:srgbClr val="F3F0FF"/>
+            </a:solidFill>
+            <a:prstDash val="solid"/>
+          </a:ln>
+        </p:spPr>
+      </p:sp>
+      <p:sp>
+        <p:nvSpPr>
+          <p:cNvPr id="12" name="Text 9"/>
+          <p:cNvSpPr/>
+          <p:nvPr/>
+        </p:nvSpPr>
+        <p:spPr>
+          <a:xfrm>
+            <a:off x="3474720" y="1261872"/>
+            <a:ext cx="2286000" cy="365760"/>
+          </a:xfrm>
+          <a:prstGeom prst="rect">
+            <a:avLst/>
+          </a:prstGeom>
+          <a:noFill/>
+          <a:ln/>
+        </p:spPr>
+        <p:txBody>
+          <a:bodyPr wrap="square" lIns="0" tIns="0" rIns="0" bIns="0" rtlCol="0" anchor="ctr"/>
+          <a:lstStyle/>
+          <a:p>
+            <a:pPr indent="0" marL="0">
+              <a:buNone/>
+            </a:pPr>
+            <a:r>
+              <a:rPr lang="en-US" sz="1600" b="1" dirty="0">
+                <a:solidFill>
+                  <a:srgbClr val="101828"/>
+                </a:solidFill>
+                <a:latin typeface="Inter" pitchFamily="34" charset="0"/>
+                <a:ea typeface="Inter" pitchFamily="34" charset="-122"/>
+                <a:cs typeface="Inter" pitchFamily="34" charset="-120"/>
+              </a:rPr>
+              <a:t>Stages</a:t>
+            </a:r>
+            <a:endParaRPr lang="en-US" sz="1600" dirty="0"/>
+          </a:p>
+        </p:txBody>
+      </p:sp>
+      <p:sp>
+        <p:nvSpPr>
+          <p:cNvPr id="13" name="Text 10"/>
+          <p:cNvSpPr/>
+          <p:nvPr/>
+        </p:nvSpPr>
+        <p:spPr>
+          <a:xfrm>
+            <a:off x="3474720" y="1691640"/>
+            <a:ext cx="2331720" cy="2788920"/>
+          </a:xfrm>
+          <a:prstGeom prst="rect">
+            <a:avLst/>
+          </a:prstGeom>
+          <a:noFill/>
+          <a:ln/>
+        </p:spPr>
+        <p:txBody>
+          <a:bodyPr wrap="square" lIns="0" tIns="0" rIns="0" bIns="0" rtlCol="0" anchor="t"/>
+          <a:lstStyle/>
+          <a:p>
+            <a:pPr indent="0" marL="0">
+              <a:spcAft>
+                <a:spcPts val="700"/>
+              </a:spcAft>
+              <a:buNone/>
+            </a:pPr>
+            <a:r>
+              <a:rPr lang="en-US" sz="1150" dirty="0">
+                <a:solidFill>
+                  <a:srgbClr val="101828"/>
+                </a:solidFill>
+                <a:latin typeface="Inter" pitchFamily="34" charset="0"/>
+                <a:ea typeface="Inter" pitchFamily="34" charset="-122"/>
+                <a:cs typeface="Inter" pitchFamily="34" charset="-120"/>
+              </a:rPr>
+              <a:t>1  Shadow, about 3 months: decide, do not act; compare with the fraud team</a:t>
+            </a:r>
+            <a:endParaRPr lang="en-US" sz="1150" dirty="0"/>
+          </a:p>
+          <a:p>
+            <a:pPr indent="0" marL="0">
+              <a:spcAft>
+                <a:spcPts val="700"/>
+              </a:spcAft>
+              <a:buNone/>
+            </a:pPr>
+            <a:r>
+              <a:rPr lang="en-US" sz="1150" dirty="0">
+                <a:solidFill>
+                  <a:srgbClr val="101828"/>
+                </a:solidFill>
+                <a:latin typeface="Inter" pitchFamily="34" charset="0"/>
+                <a:ea typeface="Inter" pitchFamily="34" charset="-122"/>
+                <a:cs typeface="Inter" pitchFamily="34" charset="-120"/>
+              </a:rPr>
+              <a:t>2  Employees: real money, small caps, device signatures</a:t>
+            </a:r>
+            <a:endParaRPr lang="en-US" sz="1150" dirty="0"/>
+          </a:p>
+          <a:p>
+            <a:pPr indent="0" marL="0">
+              <a:spcAft>
+                <a:spcPts val="700"/>
+              </a:spcAft>
+              <a:buNone/>
+            </a:pPr>
+            <a:r>
+              <a:rPr lang="en-US" sz="1150" dirty="0">
+                <a:solidFill>
+                  <a:srgbClr val="101828"/>
+                </a:solidFill>
+                <a:latin typeface="Inter" pitchFamily="34" charset="0"/>
+                <a:ea typeface="Inter" pitchFamily="34" charset="-122"/>
+                <a:cs typeface="Inter" pitchFamily="34" charset="-120"/>
+              </a:rPr>
+              <a:t>3  Volunteer clients: subscriptions and bills, then investing</a:t>
+            </a:r>
+            <a:endParaRPr lang="en-US" sz="1150" dirty="0"/>
+          </a:p>
+        </p:txBody>
+      </p:sp>
+      <p:sp>
+        <p:nvSpPr>
+          <p:cNvPr id="14" name="Shape 11"/>
+          <p:cNvSpPr/>
+          <p:nvPr/>
+        </p:nvSpPr>
+        <p:spPr>
+          <a:xfrm>
+            <a:off x="6126480" y="1143000"/>
+            <a:ext cx="2651760" cy="3429000"/>
+          </a:xfrm>
+          <a:prstGeom prst="roundRect">
+            <a:avLst>
+              <a:gd name="adj" fmla="val 4138"/>
+            </a:avLst>
+          </a:prstGeom>
+          <a:solidFill>
+            <a:srgbClr val="E8F6F3"/>
+          </a:solidFill>
+          <a:ln w="12700">
+            <a:solidFill>
+              <a:srgbClr val="E8F6F3"/>
+            </a:solidFill>
+            <a:prstDash val="solid"/>
+          </a:ln>
+        </p:spPr>
+      </p:sp>
+      <p:sp>
+        <p:nvSpPr>
+          <p:cNvPr id="15" name="Text 12"/>
+          <p:cNvSpPr/>
+          <p:nvPr/>
+        </p:nvSpPr>
+        <p:spPr>
+          <a:xfrm>
+            <a:off x="6309360" y="1261872"/>
+            <a:ext cx="2286000" cy="365760"/>
+          </a:xfrm>
+          <a:prstGeom prst="rect">
+            <a:avLst/>
+          </a:prstGeom>
+          <a:noFill/>
+          <a:ln/>
+        </p:spPr>
+        <p:txBody>
+          <a:bodyPr wrap="square" lIns="0" tIns="0" rIns="0" bIns="0" rtlCol="0" anchor="ctr"/>
+          <a:lstStyle/>
+          <a:p>
+            <a:pPr indent="0" marL="0">
+              <a:buNone/>
+            </a:pPr>
+            <a:r>
+              <a:rPr lang="en-US" sz="1600" b="1" dirty="0">
+                <a:solidFill>
+                  <a:srgbClr val="101828"/>
+                </a:solidFill>
+                <a:latin typeface="Inter" pitchFamily="34" charset="0"/>
+                <a:ea typeface="Inter" pitchFamily="34" charset="-122"/>
+                <a:cs typeface="Inter" pitchFamily="34" charset="-120"/>
+              </a:rPr>
+              <a:t>What we measure</a:t>
+            </a:r>
+            <a:endParaRPr lang="en-US" sz="1600" dirty="0"/>
+          </a:p>
+        </p:txBody>
+      </p:sp>
+      <p:sp>
+        <p:nvSpPr>
+          <p:cNvPr id="16" name="Text 13"/>
+          <p:cNvSpPr/>
+          <p:nvPr/>
+        </p:nvSpPr>
+        <p:spPr>
+          <a:xfrm>
+            <a:off x="6309360" y="1691640"/>
+            <a:ext cx="2331720" cy="2788920"/>
+          </a:xfrm>
+          <a:prstGeom prst="rect">
+            <a:avLst/>
+          </a:prstGeom>
+          <a:noFill/>
+          <a:ln/>
+        </p:spPr>
+        <p:txBody>
+          <a:bodyPr wrap="square" lIns="0" tIns="0" rIns="0" bIns="0" rtlCol="0" anchor="t"/>
+          <a:lstStyle/>
+          <a:p>
+            <a:pPr marL="342900" indent="-342900">
+              <a:spcAft>
+                <a:spcPts val="700"/>
+              </a:spcAft>
+              <a:buSzPct val="100000"/>
+              <a:buChar char="•"/>
+            </a:pPr>
+            <a:r>
+              <a:rPr lang="en-US" sz="1150" dirty="0">
+                <a:solidFill>
+                  <a:srgbClr val="101828"/>
+                </a:solidFill>
+                <a:latin typeface="Inter" pitchFamily="34" charset="0"/>
+                <a:ea typeface="Inter" pitchFamily="34" charset="-122"/>
+                <a:cs typeface="Inter" pitchFamily="34" charset="-120"/>
+              </a:rPr>
+              <a:t>Attacks stopped vs the fraud team</a:t>
+            </a:r>
+            <a:endParaRPr lang="en-US" sz="1150" dirty="0"/>
+          </a:p>
+          <a:p>
+            <a:pPr marL="342900" indent="-342900">
+              <a:spcAft>
+                <a:spcPts val="700"/>
+              </a:spcAft>
+              <a:buSzPct val="100000"/>
+              <a:buChar char="•"/>
+            </a:pPr>
+            <a:r>
+              <a:rPr lang="en-US" sz="1150" dirty="0">
+                <a:solidFill>
+                  <a:srgbClr val="101828"/>
+                </a:solidFill>
+                <a:latin typeface="Inter" pitchFamily="34" charset="0"/>
+                <a:ea typeface="Inter" pitchFamily="34" charset="-122"/>
+                <a:cs typeface="Inter" pitchFamily="34" charset="-120"/>
+              </a:rPr>
+              <a:t>Cards that asked without need</a:t>
+            </a:r>
+            <a:endParaRPr lang="en-US" sz="1150" dirty="0"/>
+          </a:p>
+          <a:p>
+            <a:pPr marL="342900" indent="-342900">
+              <a:spcAft>
+                <a:spcPts val="700"/>
+              </a:spcAft>
+              <a:buSzPct val="100000"/>
+              <a:buChar char="•"/>
+            </a:pPr>
+            <a:r>
+              <a:rPr lang="en-US" sz="1150" dirty="0">
+                <a:solidFill>
+                  <a:srgbClr val="101828"/>
+                </a:solidFill>
+                <a:latin typeface="Inter" pitchFamily="34" charset="0"/>
+                <a:ea typeface="Inter" pitchFamily="34" charset="-122"/>
+                <a:cs typeface="Inter" pitchFamily="34" charset="-120"/>
+              </a:rPr>
+              <a:t>Payments outside a mandate: 0</a:t>
+            </a:r>
+            <a:endParaRPr lang="en-US" sz="1150" dirty="0"/>
+          </a:p>
+          <a:p>
+            <a:pPr marL="342900" indent="-342900">
+              <a:spcAft>
+                <a:spcPts val="700"/>
+              </a:spcAft>
+              <a:buSzPct val="100000"/>
+              <a:buChar char="•"/>
+            </a:pPr>
+            <a:r>
+              <a:rPr lang="en-US" sz="1150" dirty="0">
+                <a:solidFill>
+                  <a:srgbClr val="101828"/>
+                </a:solidFill>
+                <a:latin typeface="Inter" pitchFamily="34" charset="0"/>
+                <a:ea typeface="Inter" pitchFamily="34" charset="-122"/>
+                <a:cs typeface="Inter" pitchFamily="34" charset="-120"/>
+              </a:rPr>
+              <a:t>Token cost per client: $0.0043 a month</a:t>
+            </a:r>
+            <a:endParaRPr lang="en-US" sz="1150" dirty="0"/>
+          </a:p>
+        </p:txBody>
+      </p:sp>
+    </p:spTree>
+  </p:cSld>
+  <p:clrMapOvr>
+    <a:masterClrMapping/>
+  </p:clrMapOvr>
+</p:sld>
+</file>
+
+<file path=ppt/slides/slide15.xml><?xml version="1.0" encoding="utf-8"?>
+<p:sld xmlns:a="http://schemas.openxmlformats.org/drawingml/2006/main" xmlns:r="http://schemas.openxmlformats.org/officeDocument/2006/relationships" xmlns:p="http://schemas.openxmlformats.org/presentationml/2006/main">
+  <p:cSld name="Slide 15">
+    <p:bg>
+      <p:bgPr>
+        <a:solidFill>
+          <a:srgbClr val="FFFFFF"/>
+        </a:solidFill>
+      </p:bgPr>
+    </p:bg>
+    <p:spTree>
+      <p:nvGrpSpPr>
+        <p:cNvPr id="1" name=""/>
+        <p:cNvGrpSpPr/>
+        <p:nvPr/>
+      </p:nvGrpSpPr>
+      <p:grpSpPr>
+        <a:xfrm>
+          <a:off x="0" y="0"/>
+          <a:ext cx="0" cy="0"/>
+          <a:chOff x="0" y="0"/>
+          <a:chExt cx="0" cy="0"/>
+        </a:xfrm>
+      </p:grpSpPr>
+      <p:sp>
+        <p:nvSpPr>
+          <p:cNvPr id="2" name="Text 0"/>
+          <p:cNvSpPr/>
+          <p:nvPr/>
+        </p:nvSpPr>
+        <p:spPr>
+          <a:xfrm>
+            <a:off x="457200" y="384048"/>
+            <a:ext cx="8229600" cy="548640"/>
+          </a:xfrm>
+          <a:prstGeom prst="rect">
+            <a:avLst/>
+          </a:prstGeom>
+          <a:noFill/>
+          <a:ln/>
+        </p:spPr>
+        <p:txBody>
+          <a:bodyPr wrap="square" lIns="0" tIns="0" rIns="0" bIns="0" rtlCol="0" anchor="ctr"/>
+          <a:lstStyle/>
+          <a:p>
+            <a:pPr indent="0" marL="0">
+              <a:buNone/>
+            </a:pPr>
+            <a:r>
+              <a:rPr lang="en-US" sz="2500" b="1" dirty="0">
+                <a:solidFill>
+                  <a:srgbClr val="101828"/>
+                </a:solidFill>
+                <a:latin typeface="Inter" pitchFamily="34" charset="0"/>
+                <a:ea typeface="Inter" pitchFamily="34" charset="-122"/>
+                <a:cs typeface="Inter" pitchFamily="34" charset="-120"/>
+              </a:rPr>
+              <a:t>Results and what comes next</a:t>
+            </a:r>
+            <a:endParaRPr lang="en-US" sz="2500" dirty="0"/>
+          </a:p>
+        </p:txBody>
+      </p:sp>
+      <p:sp>
+        <p:nvSpPr>
+          <p:cNvPr id="3" name="Shape 1"/>
+          <p:cNvSpPr/>
+          <p:nvPr/>
+        </p:nvSpPr>
+        <p:spPr>
+          <a:xfrm>
+            <a:off x="457200" y="4754880"/>
+            <a:ext cx="210312" cy="210312"/>
+          </a:xfrm>
+          <a:prstGeom prst="roundRect">
+            <a:avLst>
+              <a:gd name="adj" fmla="val 22000"/>
+            </a:avLst>
+          </a:prstGeom>
+          <a:solidFill>
+            <a:srgbClr val="C2361F"/>
+          </a:solidFill>
+          <a:ln w="12700">
+            <a:solidFill>
+              <a:srgbClr val="C2361F"/>
+            </a:solidFill>
+            <a:prstDash val="solid"/>
+          </a:ln>
+        </p:spPr>
+      </p:sp>
+      <p:sp>
+        <p:nvSpPr>
+          <p:cNvPr id="4" name="Text 2"/>
+          <p:cNvSpPr/>
+          <p:nvPr/>
+        </p:nvSpPr>
+        <p:spPr>
+          <a:xfrm>
+            <a:off x="457200" y="4754880"/>
+            <a:ext cx="210312" cy="210312"/>
+          </a:xfrm>
+          <a:prstGeom prst="rect">
+            <a:avLst/>
+          </a:prstGeom>
+          <a:noFill/>
+          <a:ln/>
+        </p:spPr>
+        <p:txBody>
+          <a:bodyPr wrap="square" lIns="0" tIns="0" rIns="0" bIns="0" rtlCol="0" anchor="ctr"/>
+          <a:lstStyle/>
+          <a:p>
+            <a:pPr algn="ctr" indent="0" marL="0">
+              <a:buNone/>
+            </a:pPr>
+            <a:r>
+              <a:rPr lang="en-US" sz="920" dirty="0">
+                <a:solidFill>
+                  <a:srgbClr val="FFFFFF"/>
+                </a:solidFill>
+                <a:latin typeface="Noto Sans CJK SC" pitchFamily="34" charset="0"/>
+                <a:ea typeface="Noto Sans CJK SC" pitchFamily="34" charset="-122"/>
+                <a:cs typeface="Noto Sans CJK SC" pitchFamily="34" charset="-120"/>
+              </a:rPr>
+              <a:t>守</a:t>
+            </a:r>
+            <a:endParaRPr lang="en-US" sz="920" dirty="0"/>
+          </a:p>
+        </p:txBody>
+      </p:sp>
+      <p:sp>
+        <p:nvSpPr>
+          <p:cNvPr id="5" name="Text 3"/>
+          <p:cNvSpPr/>
+          <p:nvPr/>
+        </p:nvSpPr>
+        <p:spPr>
+          <a:xfrm>
+            <a:off x="731520" y="4754880"/>
+            <a:ext cx="1828800" cy="210312"/>
+          </a:xfrm>
+          <a:prstGeom prst="rect">
+            <a:avLst/>
+          </a:prstGeom>
+          <a:noFill/>
+          <a:ln/>
+        </p:spPr>
+        <p:txBody>
+          <a:bodyPr wrap="square" lIns="0" tIns="0" rIns="0" bIns="0" rtlCol="0" anchor="ctr"/>
+          <a:lstStyle/>
+          <a:p>
+            <a:pPr indent="0" marL="0">
+              <a:buNone/>
+            </a:pPr>
+            <a:r>
+              <a:rPr lang="en-US" sz="900" b="1" dirty="0">
+                <a:solidFill>
+                  <a:srgbClr val="101828"/>
+                </a:solidFill>
+                <a:latin typeface="Inter" pitchFamily="34" charset="0"/>
+                <a:ea typeface="Inter" pitchFamily="34" charset="-122"/>
+                <a:cs typeface="Inter" pitchFamily="34" charset="-120"/>
+              </a:rPr>
+              <a:t>Guardian</a:t>
+            </a:r>
+            <a:endParaRPr lang="en-US" sz="900" dirty="0"/>
+          </a:p>
+        </p:txBody>
+      </p:sp>
+      <p:sp>
+        <p:nvSpPr>
+          <p:cNvPr id="6" name="Text 4"/>
+          <p:cNvSpPr/>
+          <p:nvPr/>
+        </p:nvSpPr>
+        <p:spPr>
+          <a:xfrm>
+            <a:off x="6858000" y="4754880"/>
+            <a:ext cx="1828800" cy="210312"/>
+          </a:xfrm>
+          <a:prstGeom prst="rect">
+            <a:avLst/>
+          </a:prstGeom>
+          <a:noFill/>
+          <a:ln/>
+        </p:spPr>
+        <p:txBody>
+          <a:bodyPr wrap="square" lIns="0" tIns="0" rIns="0" bIns="0" rtlCol="0" anchor="ctr"/>
+          <a:lstStyle/>
+          <a:p>
+            <a:pPr algn="r" indent="0" marL="0">
+              <a:buNone/>
+            </a:pPr>
+            <a:r>
+              <a:rPr lang="en-US" sz="900" dirty="0">
+                <a:solidFill>
+                  <a:srgbClr val="667085"/>
+                </a:solidFill>
+                <a:latin typeface="Inter" pitchFamily="34" charset="0"/>
+                <a:ea typeface="Inter" pitchFamily="34" charset="-122"/>
+                <a:cs typeface="Inter" pitchFamily="34" charset="-120"/>
+              </a:rPr>
+              <a:t>15 / 15</a:t>
             </a:r>
             <a:endParaRPr lang="en-US" sz="900" dirty="0"/>
           </a:p>
@@ -8285,7 +9081,7 @@
                 <a:ea typeface="Inter" pitchFamily="34" charset="-122"/>
                 <a:cs typeface="Inter" pitchFamily="34" charset="-120"/>
               </a:rPr>
-              <a:t>functional tasks, EN / RU / ZH</a:t>
+              <a:t>functional tasks, EN / RU / ZH; 44/48 live</a:t>
             </a:r>
             <a:endParaRPr lang="en-US" sz="1050" dirty="0"/>
           </a:p>
@@ -8682,7 +9478,7 @@
                 <a:ea typeface="Inter" pitchFamily="34" charset="-122"/>
                 <a:cs typeface="Inter" pitchFamily="34" charset="-120"/>
               </a:rPr>
-              <a:t>Live runs with real models; measured cost replaces the estimate</a:t>
+              <a:t>Pilot with a bank: shadow mode next to its fraud team first</a:t>
             </a:r>
             <a:endParaRPr lang="en-US" sz="1300" dirty="0"/>
           </a:p>
@@ -8745,7 +9541,7 @@
                 <a:ea typeface="Inter" pitchFamily="34" charset="-122"/>
                 <a:cs typeface="Inter" pitchFamily="34" charset="-120"/>
               </a:rPr>
-              <a:t>SD-JWT selective disclosure for mandates; pilot with a bank's fraud team</a:t>
+              <a:t>SD-JWT selective disclosure for mandates</a:t>
             </a:r>
             <a:endParaRPr lang="en-US" sz="1300" dirty="0"/>
           </a:p>
@@ -9043,7 +9839,7 @@
                 <a:ea typeface="Inter" pitchFamily="34" charset="-122"/>
                 <a:cs typeface="Inter" pitchFamily="34" charset="-120"/>
               </a:rPr>
-              <a:t>2 / 14</a:t>
+              <a:t>2 / 15</a:t>
             </a:r>
             <a:endParaRPr lang="en-US" sz="900" dirty="0"/>
           </a:p>
@@ -9831,7 +10627,7 @@
                 <a:ea typeface="Inter" pitchFamily="34" charset="-122"/>
                 <a:cs typeface="Inter" pitchFamily="34" charset="-120"/>
               </a:rPr>
-              <a:t>3 / 14</a:t>
+              <a:t>3 / 15</a:t>
             </a:r>
             <a:endParaRPr lang="en-US" sz="900" dirty="0"/>
           </a:p>
@@ -10517,7 +11313,7 @@
                 <a:ea typeface="Inter" pitchFamily="34" charset="-122"/>
                 <a:cs typeface="Inter" pitchFamily="34" charset="-120"/>
               </a:rPr>
-              <a:t>4 / 14</a:t>
+              <a:t>4 / 15</a:t>
             </a:r>
             <a:endParaRPr lang="en-US" sz="900" dirty="0"/>
           </a:p>
@@ -12293,7 +13089,7 @@
                 <a:ea typeface="Inter" pitchFamily="34" charset="-122"/>
                 <a:cs typeface="Inter" pitchFamily="34" charset="-120"/>
               </a:rPr>
-              <a:t>What the client sees</a:t>
+              <a:t>Three scenes to remember</a:t>
             </a:r>
             <a:endParaRPr lang="en-US" sz="2500" dirty="0"/>
           </a:p>
@@ -12437,7 +13233,7 @@
                 <a:ea typeface="Inter" pitchFamily="34" charset="-122"/>
                 <a:cs typeface="Inter" pitchFamily="34" charset="-120"/>
               </a:rPr>
-              <a:t>5 / 14</a:t>
+              <a:t>5 / 15</a:t>
             </a:r>
             <a:endParaRPr lang="en-US" sz="900" dirty="0"/>
           </a:p>
@@ -12459,8 +13255,8 @@
         </p:blipFill>
         <p:spPr>
           <a:xfrm>
-            <a:off x="914400" y="1188720"/>
-            <a:ext cx="3108960" cy="3152140"/>
+            <a:off x="457200" y="1097280"/>
+            <a:ext cx="2560320" cy="2595880"/>
           </a:xfrm>
           <a:prstGeom prst="rect">
             <a:avLst/>
@@ -12475,12 +13271,12 @@
         </p:nvSpPr>
         <p:spPr>
           <a:xfrm>
-            <a:off x="914400" y="1188720"/>
-            <a:ext cx="3108960" cy="3152140"/>
+            <a:off x="457200" y="1097280"/>
+            <a:ext cx="2560320" cy="2595880"/>
           </a:xfrm>
           <a:prstGeom prst="roundRect">
             <a:avLst>
-              <a:gd name="adj" fmla="val 1765"/>
+              <a:gd name="adj" fmla="val 2143"/>
             </a:avLst>
           </a:prstGeom>
           <a:ln w="12700">
@@ -12499,24 +13295,24 @@
         </p:nvSpPr>
         <p:spPr>
           <a:xfrm>
-            <a:off x="457200" y="4377436"/>
-            <a:ext cx="4023360" cy="274320"/>
-          </a:xfrm>
-          <a:prstGeom prst="rect">
-            <a:avLst/>
-          </a:prstGeom>
-          <a:noFill/>
-          <a:ln/>
-        </p:spPr>
-        <p:txBody>
-          <a:bodyPr wrap="square" lIns="0" tIns="0" rIns="0" bIns="0" rtlCol="0" anchor="ctr"/>
-          <a:lstStyle/>
-          <a:p>
-            <a:pPr algn="ctr" indent="0" marL="0">
-              <a:buNone/>
-            </a:pPr>
-            <a:r>
-              <a:rPr lang="en-US" sz="1100" dirty="0">
+            <a:off x="457200" y="3766312"/>
+            <a:ext cx="2560320" cy="274320"/>
+          </a:xfrm>
+          <a:prstGeom prst="rect">
+            <a:avLst/>
+          </a:prstGeom>
+          <a:noFill/>
+          <a:ln/>
+        </p:spPr>
+        <p:txBody>
+          <a:bodyPr wrap="square" lIns="0" tIns="0" rIns="0" bIns="0" rtlCol="0" anchor="ctr"/>
+          <a:lstStyle/>
+          <a:p>
+            <a:pPr indent="0" marL="0">
+              <a:buNone/>
+            </a:pPr>
+            <a:r>
+              <a:rPr lang="en-US" sz="1200" b="1" dirty="0">
                 <a:solidFill>
                   <a:srgbClr val="101828"/>
                 </a:solidFill>
@@ -12524,15 +13320,54 @@
                 <a:ea typeface="Inter" pitchFamily="34" charset="-122"/>
                 <a:cs typeface="Inter" pitchFamily="34" charset="-120"/>
               </a:rPr>
-              <a:t>A card: every field with its source, signed with the device key</a:t>
-            </a:r>
-            <a:endParaRPr lang="en-US" sz="1100" dirty="0"/>
+              <a:t>1  A payment the client can prove</a:t>
+            </a:r>
+            <a:endParaRPr lang="en-US" sz="1200" dirty="0"/>
+          </a:p>
+        </p:txBody>
+      </p:sp>
+      <p:sp>
+        <p:nvSpPr>
+          <p:cNvPr id="11" name="Text 7"/>
+          <p:cNvSpPr/>
+          <p:nvPr/>
+        </p:nvSpPr>
+        <p:spPr>
+          <a:xfrm>
+            <a:off x="457200" y="4040632"/>
+            <a:ext cx="2560320" cy="365760"/>
+          </a:xfrm>
+          <a:prstGeom prst="rect">
+            <a:avLst/>
+          </a:prstGeom>
+          <a:noFill/>
+          <a:ln/>
+        </p:spPr>
+        <p:txBody>
+          <a:bodyPr wrap="square" lIns="0" tIns="0" rIns="0" bIns="0" rtlCol="0" anchor="t"/>
+          <a:lstStyle/>
+          <a:p>
+            <a:pPr indent="0" marL="0">
+              <a:buNone/>
+            </a:pPr>
+            <a:r>
+              <a:rPr lang="en-US" sz="1000" dirty="0">
+                <a:solidFill>
+                  <a:srgbClr val="667085"/>
+                </a:solidFill>
+                <a:latin typeface="Inter" pitchFamily="34" charset="0"/>
+                <a:ea typeface="Inter" pitchFamily="34" charset="-122"/>
+                <a:cs typeface="Inter" pitchFamily="34" charset="-120"/>
+              </a:rPr>
+              <a:t>card, device signature, then a standing permission</a:t>
+            </a:r>
+            <a:endParaRPr lang="en-US" sz="1000" dirty="0"/>
           </a:p>
         </p:txBody>
       </p:sp>
       <p:pic>
         <p:nvPicPr>
-          <p:cNvPr id="11" name="Image 1" descr="/workspace/ShenzhenFinTechathonTopicA/docs/media/06_fake_bill_chat.png">    </p:cNvPr>
+          <p:cNvPr id="12" name="Image 1" descr="/workspace/ShenzhenFinTechathonTopicA/docs/media/06_fake_bill_chat.png">    </p:cNvPr>
           <p:cNvPicPr>
             <a:picLocks noChangeAspect="1"/>
           </p:cNvPicPr>
@@ -12546,8 +13381,8 @@
         </p:blipFill>
         <p:spPr>
           <a:xfrm>
-            <a:off x="5120640" y="1188720"/>
-            <a:ext cx="3108960" cy="3152140"/>
+            <a:off x="3291840" y="1097280"/>
+            <a:ext cx="2560320" cy="2595880"/>
           </a:xfrm>
           <a:prstGeom prst="rect">
             <a:avLst/>
@@ -12556,18 +13391,18 @@
       </p:pic>
       <p:sp>
         <p:nvSpPr>
-          <p:cNvPr id="12" name="Shape 7"/>
-          <p:cNvSpPr/>
-          <p:nvPr/>
-        </p:nvSpPr>
-        <p:spPr>
-          <a:xfrm>
-            <a:off x="5120640" y="1188720"/>
-            <a:ext cx="3108960" cy="3152140"/>
+          <p:cNvPr id="13" name="Shape 8"/>
+          <p:cNvSpPr/>
+          <p:nvPr/>
+        </p:nvSpPr>
+        <p:spPr>
+          <a:xfrm>
+            <a:off x="3291840" y="1097280"/>
+            <a:ext cx="2560320" cy="2595880"/>
           </a:xfrm>
           <a:prstGeom prst="roundRect">
             <a:avLst>
-              <a:gd name="adj" fmla="val 1765"/>
+              <a:gd name="adj" fmla="val 2143"/>
             </a:avLst>
           </a:prstGeom>
           <a:ln w="12700">
@@ -12580,30 +13415,30 @@
       </p:sp>
       <p:sp>
         <p:nvSpPr>
-          <p:cNvPr id="13" name="Text 8"/>
-          <p:cNvSpPr/>
-          <p:nvPr/>
-        </p:nvSpPr>
-        <p:spPr>
-          <a:xfrm>
-            <a:off x="4663440" y="4377436"/>
-            <a:ext cx="4023360" cy="274320"/>
-          </a:xfrm>
-          <a:prstGeom prst="rect">
-            <a:avLst/>
-          </a:prstGeom>
-          <a:noFill/>
-          <a:ln/>
-        </p:spPr>
-        <p:txBody>
-          <a:bodyPr wrap="square" lIns="0" tIns="0" rIns="0" bIns="0" rtlCol="0" anchor="ctr"/>
-          <a:lstStyle/>
-          <a:p>
-            <a:pPr algn="ctr" indent="0" marL="0">
-              <a:buNone/>
-            </a:pPr>
-            <a:r>
-              <a:rPr lang="en-US" sz="1100" dirty="0">
+          <p:cNvPr id="14" name="Text 9"/>
+          <p:cNvSpPr/>
+          <p:nvPr/>
+        </p:nvSpPr>
+        <p:spPr>
+          <a:xfrm>
+            <a:off x="3291840" y="3766312"/>
+            <a:ext cx="2560320" cy="274320"/>
+          </a:xfrm>
+          <a:prstGeom prst="rect">
+            <a:avLst/>
+          </a:prstGeom>
+          <a:noFill/>
+          <a:ln/>
+        </p:spPr>
+        <p:txBody>
+          <a:bodyPr wrap="square" lIns="0" tIns="0" rIns="0" bIns="0" rtlCol="0" anchor="ctr"/>
+          <a:lstStyle/>
+          <a:p>
+            <a:pPr indent="0" marL="0">
+              <a:buNone/>
+            </a:pPr>
+            <a:r>
+              <a:rPr lang="en-US" sz="1200" b="1" dirty="0">
                 <a:solidFill>
                   <a:srgbClr val="101828"/>
                 </a:solidFill>
@@ -12611,9 +13446,174 @@
                 <a:ea typeface="Inter" pitchFamily="34" charset="-122"/>
                 <a:cs typeface="Inter" pitchFamily="34" charset="-120"/>
               </a:rPr>
-              <a:t>A fake bill: stopped with reasons, case sent to analysts</a:t>
-            </a:r>
-            <a:endParaRPr lang="en-US" sz="1100" dirty="0"/>
+              <a:t>2  An attack that goes nowhere</a:t>
+            </a:r>
+            <a:endParaRPr lang="en-US" sz="1200" dirty="0"/>
+          </a:p>
+        </p:txBody>
+      </p:sp>
+      <p:sp>
+        <p:nvSpPr>
+          <p:cNvPr id="15" name="Text 10"/>
+          <p:cNvSpPr/>
+          <p:nvPr/>
+        </p:nvSpPr>
+        <p:spPr>
+          <a:xfrm>
+            <a:off x="3291840" y="4040632"/>
+            <a:ext cx="2560320" cy="365760"/>
+          </a:xfrm>
+          <a:prstGeom prst="rect">
+            <a:avLst/>
+          </a:prstGeom>
+          <a:noFill/>
+          <a:ln/>
+        </p:spPr>
+        <p:txBody>
+          <a:bodyPr wrap="square" lIns="0" tIns="0" rIns="0" bIns="0" rtlCol="0" anchor="t"/>
+          <a:lstStyle/>
+          <a:p>
+            <a:pPr indent="0" marL="0">
+              <a:buNone/>
+            </a:pPr>
+            <a:r>
+              <a:rPr lang="en-US" sz="1000" dirty="0">
+                <a:solidFill>
+                  <a:srgbClr val="667085"/>
+                </a:solidFill>
+                <a:latin typeface="Inter" pitchFamily="34" charset="0"/>
+                <a:ea typeface="Inter" pitchFamily="34" charset="-122"/>
+                <a:cs typeface="Inter" pitchFamily="34" charset="-120"/>
+              </a:rPr>
+              <a:t>fake bill with a hidden instruction: stopped, case to analysts</a:t>
+            </a:r>
+            <a:endParaRPr lang="en-US" sz="1000" dirty="0"/>
+          </a:p>
+        </p:txBody>
+      </p:sp>
+      <p:pic>
+        <p:nvPicPr>
+          <p:cNvPr id="16" name="Image 2" descr="/workspace/ShenzhenFinTechathonTopicA/docs/media/12_invest_chat.png">    </p:cNvPr>
+          <p:cNvPicPr>
+            <a:picLocks noChangeAspect="1"/>
+          </p:cNvPicPr>
+          <p:nvPr/>
+        </p:nvPicPr>
+        <p:blipFill>
+          <a:blip r:embed="rId3"/>
+          <a:stretch>
+            <a:fillRect/>
+          </a:stretch>
+        </p:blipFill>
+        <p:spPr>
+          <a:xfrm>
+            <a:off x="6126480" y="1097280"/>
+            <a:ext cx="2560320" cy="2595880"/>
+          </a:xfrm>
+          <a:prstGeom prst="rect">
+            <a:avLst/>
+          </a:prstGeom>
+        </p:spPr>
+      </p:pic>
+      <p:sp>
+        <p:nvSpPr>
+          <p:cNvPr id="17" name="Shape 11"/>
+          <p:cNvSpPr/>
+          <p:nvPr/>
+        </p:nvSpPr>
+        <p:spPr>
+          <a:xfrm>
+            <a:off x="6126480" y="1097280"/>
+            <a:ext cx="2560320" cy="2595880"/>
+          </a:xfrm>
+          <a:prstGeom prst="roundRect">
+            <a:avLst>
+              <a:gd name="adj" fmla="val 2143"/>
+            </a:avLst>
+          </a:prstGeom>
+          <a:ln w="12700">
+            <a:solidFill>
+              <a:srgbClr val="E4E7EC"/>
+            </a:solidFill>
+            <a:prstDash val="solid"/>
+          </a:ln>
+        </p:spPr>
+      </p:sp>
+      <p:sp>
+        <p:nvSpPr>
+          <p:cNvPr id="18" name="Text 12"/>
+          <p:cNvSpPr/>
+          <p:nvPr/>
+        </p:nvSpPr>
+        <p:spPr>
+          <a:xfrm>
+            <a:off x="6126480" y="3766312"/>
+            <a:ext cx="2560320" cy="274320"/>
+          </a:xfrm>
+          <a:prstGeom prst="rect">
+            <a:avLst/>
+          </a:prstGeom>
+          <a:noFill/>
+          <a:ln/>
+        </p:spPr>
+        <p:txBody>
+          <a:bodyPr wrap="square" lIns="0" tIns="0" rIns="0" bIns="0" rtlCol="0" anchor="ctr"/>
+          <a:lstStyle/>
+          <a:p>
+            <a:pPr indent="0" marL="0">
+              <a:buNone/>
+            </a:pPr>
+            <a:r>
+              <a:rPr lang="en-US" sz="1200" b="1" dirty="0">
+                <a:solidFill>
+                  <a:srgbClr val="101828"/>
+                </a:solidFill>
+                <a:latin typeface="Inter" pitchFamily="34" charset="0"/>
+                <a:ea typeface="Inter" pitchFamily="34" charset="-122"/>
+                <a:cs typeface="Inter" pitchFamily="34" charset="-120"/>
+              </a:rPr>
+              <a:t>3  A real exchange, in a mandate</a:t>
+            </a:r>
+            <a:endParaRPr lang="en-US" sz="1200" dirty="0"/>
+          </a:p>
+        </p:txBody>
+      </p:sp>
+      <p:sp>
+        <p:nvSpPr>
+          <p:cNvPr id="19" name="Text 13"/>
+          <p:cNvSpPr/>
+          <p:nvPr/>
+        </p:nvSpPr>
+        <p:spPr>
+          <a:xfrm>
+            <a:off x="6126480" y="4040632"/>
+            <a:ext cx="2560320" cy="365760"/>
+          </a:xfrm>
+          <a:prstGeom prst="rect">
+            <a:avLst/>
+          </a:prstGeom>
+          <a:noFill/>
+          <a:ln/>
+        </p:spPr>
+        <p:txBody>
+          <a:bodyPr wrap="square" lIns="0" tIns="0" rIns="0" bIns="0" rtlCol="0" anchor="t"/>
+          <a:lstStyle/>
+          <a:p>
+            <a:pPr indent="0" marL="0">
+              <a:buNone/>
+            </a:pPr>
+            <a:r>
+              <a:rPr lang="en-US" sz="1000" dirty="0">
+                <a:solidFill>
+                  <a:srgbClr val="667085"/>
+                </a:solidFill>
+                <a:latin typeface="Inter" pitchFamily="34" charset="0"/>
+                <a:ea typeface="Inter" pitchFamily="34" charset="-122"/>
+                <a:cs typeface="Inter" pitchFamily="34" charset="-120"/>
+              </a:rPr>
+              <a:t>SPY on Alpaca paper, filled at $767.57</a:t>
+            </a:r>
+            <a:endParaRPr lang="en-US" sz="1000" dirty="0"/>
           </a:p>
         </p:txBody>
       </p:sp>
@@ -12826,7 +13826,7 @@
                 <a:ea typeface="Inter" pitchFamily="34" charset="-122"/>
                 <a:cs typeface="Inter" pitchFamily="34" charset="-120"/>
               </a:rPr>
-              <a:t>6 / 14</a:t>
+              <a:t>6 / 15</a:t>
             </a:r>
             <a:endParaRPr lang="en-US" sz="900" dirty="0"/>
           </a:p>
@@ -13065,7 +14065,7 @@
                 <a:ea typeface="Inter" pitchFamily="34" charset="-122"/>
                 <a:cs typeface="Inter" pitchFamily="34" charset="-120"/>
               </a:rPr>
-              <a:t>7 / 14</a:t>
+              <a:t>7 / 15</a:t>
             </a:r>
             <a:endParaRPr lang="en-US" sz="900" dirty="0"/>
           </a:p>
@@ -14998,7 +15998,7 @@
                 <a:ea typeface="Inter" pitchFamily="34" charset="-122"/>
                 <a:cs typeface="Inter" pitchFamily="34" charset="-120"/>
               </a:rPr>
-              <a:t>8 / 14</a:t>
+              <a:t>8 / 15</a:t>
             </a:r>
             <a:endParaRPr lang="en-US" sz="900" dirty="0"/>
           </a:p>
@@ -16489,7 +17489,7 @@
                 <a:ea typeface="Inter" pitchFamily="34" charset="-122"/>
                 <a:cs typeface="Inter" pitchFamily="34" charset="-120"/>
               </a:rPr>
-              <a:t>9 / 14</a:t>
+              <a:t>9 / 15</a:t>
             </a:r>
             <a:endParaRPr lang="en-US" sz="900" dirty="0"/>
           </a:p>

</xml_diff>